<commit_message>
auto(analyze): portfolio PPT 2026-07-05T23:49:37Z
</commit_message>
<xml_diff>
--- a/reports/portfolio/2026-07-06.pptx
+++ b/reports/portfolio/2026-07-06.pptx
@@ -3193,7 +3193,7 @@
                   <a:srgbClr val="555555"/>
                 </a:solidFill>
               </a:rPr>
-              <a:t>분석 기간: 2026-06-29 00:00 ~ 2026-07-06 00:15</a:t>
+              <a:t>분석 기간: 2026-06-29 00:00 ~ 2026-07-06 08:45</a:t>
             </a:r>
           </a:p>
           <a:p>
@@ -3204,7 +3204,7 @@
                   <a:srgbClr val="555555"/>
                 </a:solidFill>
               </a:rPr>
-              <a:t>데이터: 총 2,020건 · 5분 해상도 · 전국 계통 기준</a:t>
+              <a:t>데이터: 총 2,122건 · 5분 해상도 · 전국 계통 기준</a:t>
             </a:r>
           </a:p>
           <a:p>
@@ -3215,7 +3215,7 @@
                   <a:srgbClr val="555555"/>
                 </a:solidFill>
               </a:rPr>
-              <a:t>생성일: 2026-07-06 07:44 KST</a:t>
+              <a:t>생성일: 2026-07-06 08:49 KST</a:t>
             </a:r>
           </a:p>
         </p:txBody>
@@ -4170,7 +4170,7 @@
                   <a:srgbClr val="555555"/>
                 </a:solidFill>
               </a:rPr>
-              <a:t>•  총 2,020건 · 168시간 분량 5분 해상도 수집·분석</a:t>
+              <a:t>•  총 2,122건 · 177시간 분량 5분 해상도 수집·분석</a:t>
             </a:r>
           </a:p>
           <a:p>
@@ -4185,7 +4185,7 @@
                   <a:srgbClr val="555555"/>
                 </a:solidFill>
               </a:rPr>
-              <a:t>•  다층 이상탐지 결과: EWMA:5건 · CUSUM:141건 · IForest:0건 · 잔차:2건 · LSTM-AE:스킵</a:t>
+              <a:t>•  다층 이상탐지 결과: EWMA:5건 · CUSUM:145건 · IForest:0건 · 잔차:4건 · LSTM-AE:스킵</a:t>
             </a:r>
           </a:p>
           <a:p>

</xml_diff>

<commit_message>
auto(analyze): portfolio PPT 2026-07-06T11:09:14Z
</commit_message>
<xml_diff>
--- a/reports/portfolio/2026-07-06.pptx
+++ b/reports/portfolio/2026-07-06.pptx
@@ -3193,7 +3193,7 @@
                   <a:srgbClr val="555555"/>
                 </a:solidFill>
               </a:rPr>
-              <a:t>분석 기간: 2026-06-29 00:00 ~ 2026-07-06 08:45</a:t>
+              <a:t>분석 기간: 2026-06-29 00:00 ~ 2026-07-06 20:05</a:t>
             </a:r>
           </a:p>
           <a:p>
@@ -3204,7 +3204,7 @@
                   <a:srgbClr val="555555"/>
                 </a:solidFill>
               </a:rPr>
-              <a:t>데이터: 총 2,122건 · 5분 해상도 · 전국 계통 기준</a:t>
+              <a:t>데이터: 총 2,258건 · 5분 해상도 · 전국 계통 기준</a:t>
             </a:r>
           </a:p>
           <a:p>
@@ -3215,7 +3215,7 @@
                   <a:srgbClr val="555555"/>
                 </a:solidFill>
               </a:rPr>
-              <a:t>생성일: 2026-07-06 08:49 KST</a:t>
+              <a:t>생성일: 2026-07-06 20:09 KST</a:t>
             </a:r>
           </a:p>
         </p:txBody>
@@ -4170,7 +4170,7 @@
                   <a:srgbClr val="555555"/>
                 </a:solidFill>
               </a:rPr>
-              <a:t>•  총 2,122건 · 177시간 분량 5분 해상도 수집·분석</a:t>
+              <a:t>•  총 2,258건 · 188시간 분량 5분 해상도 수집·분석</a:t>
             </a:r>
           </a:p>
           <a:p>
@@ -4185,7 +4185,7 @@
                   <a:srgbClr val="555555"/>
                 </a:solidFill>
               </a:rPr>
-              <a:t>•  다층 이상탐지 결과: EWMA:5건 · CUSUM:145건 · IForest:0건 · 잔차:4건 · LSTM-AE:스킵</a:t>
+              <a:t>•  다층 이상탐지 결과: EWMA:5건 · CUSUM:162건 · IForest:0건 · 잔차:4건 · LSTM-AE:스킵</a:t>
             </a:r>
           </a:p>
           <a:p>
@@ -4200,7 +4200,7 @@
                   <a:srgbClr val="555555"/>
                 </a:solidFill>
               </a:rPr>
-              <a:t>•  최대 부하: 79,027 MW (06-30 18:40)</a:t>
+              <a:t>•  최대 부하: 83,396 MW (07-06 18:45)</a:t>
             </a:r>
           </a:p>
           <a:p>

</xml_diff>

<commit_message>
auto(analyze): portfolio PPT 2026-07-06T14:39:43Z
</commit_message>
<xml_diff>
--- a/reports/portfolio/2026-07-06.pptx
+++ b/reports/portfolio/2026-07-06.pptx
@@ -3193,7 +3193,7 @@
                   <a:srgbClr val="555555"/>
                 </a:solidFill>
               </a:rPr>
-              <a:t>분석 기간: 2026-06-29 00:00 ~ 2026-07-06 20:05</a:t>
+              <a:t>분석 기간: 2026-06-29 00:00 ~ 2026-07-06 20:25</a:t>
             </a:r>
           </a:p>
           <a:p>
@@ -3204,7 +3204,7 @@
                   <a:srgbClr val="555555"/>
                 </a:solidFill>
               </a:rPr>
-              <a:t>데이터: 총 2,258건 · 5분 해상도 · 전국 계통 기준</a:t>
+              <a:t>데이터: 총 2,262건 · 5분 해상도 · 전국 계통 기준</a:t>
             </a:r>
           </a:p>
           <a:p>
@@ -3215,7 +3215,7 @@
                   <a:srgbClr val="555555"/>
                 </a:solidFill>
               </a:rPr>
-              <a:t>생성일: 2026-07-06 20:09 KST</a:t>
+              <a:t>생성일: 2026-07-06 23:39 KST</a:t>
             </a:r>
           </a:p>
         </p:txBody>
@@ -4170,7 +4170,7 @@
                   <a:srgbClr val="555555"/>
                 </a:solidFill>
               </a:rPr>
-              <a:t>•  총 2,258건 · 188시간 분량 5분 해상도 수집·분석</a:t>
+              <a:t>•  총 2,262건 · 188시간 분량 5분 해상도 수집·분석</a:t>
             </a:r>
           </a:p>
           <a:p>
@@ -4185,7 +4185,7 @@
                   <a:srgbClr val="555555"/>
                 </a:solidFill>
               </a:rPr>
-              <a:t>•  다층 이상탐지 결과: EWMA:5건 · CUSUM:162건 · IForest:0건 · 잔차:4건 · LSTM-AE:스킵</a:t>
+              <a:t>•  다층 이상탐지 결과: EWMA:5건 · CUSUM:162건 · IForest:0건 · 잔차:3건 · LSTM-AE:스킵</a:t>
             </a:r>
           </a:p>
           <a:p>

</xml_diff>